<commit_message>
fix(model): correct anomaly score normalization and update evaluation reports
</commit_message>
<xml_diff>
--- a/reports/SWaT_Evaluation_Report.pptx
+++ b/reports/SWaT_Evaluation_Report.pptx
@@ -3319,7 +3319,7 @@
                   <a:srgbClr val="8B949E"/>
                 </a:solidFill>
               </a:rPr>
-              <a:t>LightGBM . Real-Time Inference . SWaT Dataset</a:t>
+              <a:t>Isolation Forest . Real-Time Inference . SWaT Dataset</a:t>
             </a:r>
           </a:p>
         </p:txBody>
@@ -3396,7 +3396,7 @@
                   <a:srgbClr val="3FB950"/>
                 </a:solidFill>
               </a:rPr>
-              <a:t>Precision  0.994   |   Recall  0.999   |   F1  0.997   |   AUC  0.999</a:t>
+              <a:t>Precision  0.958   |   Recall  0.690   |   F1  0.802   |   AUC  0.943</a:t>
             </a:r>
           </a:p>
         </p:txBody>
@@ -3758,7 +3758,7 @@
                   <a:srgbClr val="E6EDF3"/>
                 </a:solidFill>
               </a:rPr>
-              <a:t>Detect cyber-physical attacks on industrial control systems in real-time with sub-5ms latency and &gt;99% recall, ensuring no attack event is missed.</a:t>
+              <a:t>Detect cyber-physical attacks on industrial control systems in real-time with low latency and high precision using a realistic temporal split.</a:t>
             </a:r>
           </a:p>
         </p:txBody>
@@ -3871,7 +3871,7 @@
                   <a:srgbClr val="E6EDF3"/>
                 </a:solidFill>
               </a:rPr>
-              <a:t>SWaT benchmark - 496,800 sensor records (51 features) from a real water treatment plant. Attack rate ~ 3.8 %. Merged CSV: normal + 36 attack scenarios.</a:t>
+              <a:t>SWaT benchmark - 1.44 million sensor records (51 features) from a real water treatment plant. 80/20 chronological train/test split.</a:t>
             </a:r>
           </a:p>
         </p:txBody>
@@ -3984,7 +3984,7 @@
                   <a:srgbClr val="E6EDF3"/>
                 </a:solidFill>
               </a:rPr>
-              <a:t>Incremental StandardScaler -&gt; LightGBM binary classifier (scale_pos_weight) -&gt; Streaming inference engine with ThroughputTracker -&gt; Live Streamlit dashboard.</a:t>
+              <a:t>Incremental StandardScaler -&gt; Unsupervised Isolation Forest (trained only on normal data) -&gt; Streaming engine with ThroughputTracker -&gt; Live Streamlit dashboard.</a:t>
             </a:r>
           </a:p>
         </p:txBody>
@@ -4097,7 +4097,7 @@
                   <a:srgbClr val="E6EDF3"/>
                 </a:solidFill>
               </a:rPr>
-              <a:t>Production-ready pipeline achieving 99.9% recall at 57,000 RPS with 4.23 ms mean batch latency on CPU-only hardware.</a:t>
+              <a:t>Production-ready unsupervised pipeline achieving 95.8% precision, 69.0% recall, and 0.71% false alarm rate under realistic chronological deployment.</a:t>
             </a:r>
           </a:p>
         </p:txBody>
@@ -4460,7 +4460,7 @@
                 </a:solidFill>
               </a:rPr>
               <a:t>SWaT CSV
-496K rows
+1.44M rows
 51 features</a:t>
             </a:r>
           </a:p>
@@ -4877,8 +4877,7 @@
                   <a:srgbClr val="E6EDF3"/>
                 </a:solidFill>
               </a:rPr>
-              <a:t>LightGBM
-Model</a:t>
+              <a:t>Isolation Forest</a:t>
             </a:r>
           </a:p>
         </p:txBody>
@@ -4912,9 +4911,9 @@
                   <a:srgbClr val="8B949E"/>
                 </a:solidFill>
               </a:rPr>
-              <a:t>300 trees
-scale_pos_weight
-ROC-AUC 0.999</a:t>
+              <a:t>100 estimators
+contamination=0.04
+Unsupervised</a:t>
             </a:r>
           </a:p>
         </p:txBody>
@@ -5538,7 +5537,7 @@
                   <a:srgbClr val="E6EDF3"/>
                 </a:solidFill>
               </a:rPr>
-              <a:t>LightGBM Detector - Held-Out Test Set (20%)</a:t>
+              <a:t>Isolation Forest Detector - Held-Out Test Set (20%)</a:t>
             </a:r>
           </a:p>
         </p:txBody>
@@ -5651,7 +5650,7 @@
                   <a:srgbClr val="388BFD"/>
                 </a:solidFill>
               </a:rPr>
-              <a:t>99.4%</a:t>
+              <a:t>95.8%</a:t>
             </a:r>
           </a:p>
         </p:txBody>
@@ -5798,7 +5797,7 @@
                   <a:srgbClr val="3FB950"/>
                 </a:solidFill>
               </a:rPr>
-              <a:t>99.9%</a:t>
+              <a:t>69.0%</a:t>
             </a:r>
           </a:p>
         </p:txBody>
@@ -5945,7 +5944,7 @@
                   <a:srgbClr val="D29922"/>
                 </a:solidFill>
               </a:rPr>
-              <a:t>99.7%</a:t>
+              <a:t>80.2%</a:t>
             </a:r>
           </a:p>
         </p:txBody>
@@ -6092,7 +6091,7 @@
                   <a:srgbClr val="388BFD"/>
                 </a:solidFill>
               </a:rPr>
-              <a:t>99.9%</a:t>
+              <a:t>94.3%</a:t>
             </a:r>
           </a:p>
         </p:txBody>
@@ -6521,7 +6520,7 @@
                   <a:srgbClr val="E6EDF3"/>
                 </a:solidFill>
               </a:rPr>
-              <a:t>TN  OK</a:t>
+              <a:t>TN: 232,053</a:t>
             </a:r>
           </a:p>
         </p:txBody>
@@ -6600,7 +6599,7 @@
                   <a:srgbClr val="E6EDF3"/>
                 </a:solidFill>
               </a:rPr>
-              <a:t>FP  Warning</a:t>
+              <a:t>FP: 1,670</a:t>
             </a:r>
           </a:p>
         </p:txBody>
@@ -6758,7 +6757,7 @@
                   <a:srgbClr val="E6EDF3"/>
                 </a:solidFill>
               </a:rPr>
-              <a:t>FN  Miss</a:t>
+              <a:t>FN: 16,937</a:t>
             </a:r>
           </a:p>
         </p:txBody>
@@ -6837,7 +6836,7 @@
                   <a:srgbClr val="E6EDF3"/>
                 </a:solidFill>
               </a:rPr>
-              <a:t>TP  OK</a:t>
+              <a:t>TP: 37,684</a:t>
             </a:r>
           </a:p>
         </p:txBody>
@@ -6950,7 +6949,7 @@
                   <a:srgbClr val="E6EDF3"/>
                 </a:solidFill>
               </a:rPr>
-              <a:t>Near-perfect recall (99.9%) ensures virtually no attack event goes undetected. Precision of 99.4% minimizes operator alert fatigue.</a:t>
+              <a:t>Unsupervised model learns only normal states, achieving a 95.8% precision with an extremely low false alarm rate of 0.71%. This avoids operator fatigue while catching 69.0% of siber attack events in chronological time.</a:t>
             </a:r>
           </a:p>
         </p:txBody>

</xml_diff>